<commit_message>
Update Trabajo Final Taller de programación.pptx
</commit_message>
<xml_diff>
--- a/Proyecto Final/Trabajo Final Taller de programación.pptx
+++ b/Proyecto Final/Trabajo Final Taller de programación.pptx
@@ -119,6 +119,104 @@
 </p:presentation>
 </file>
 
+<file path=ppt/revisionInfo.xml><?xml version="1.0" encoding="utf-8"?>
+<p1510:revInfo xmlns:a="http://schemas.openxmlformats.org/drawingml/2006/main" xmlns:r="http://schemas.openxmlformats.org/officeDocument/2006/relationships" xmlns:p1510="http://schemas.microsoft.com/office/powerpoint/2015/10/main">
+  <p1510:revLst>
+    <p1510:client id="{9DFD7805-24BF-4A68-BB66-FC44D414A98A}" v="5" dt="2025-11-02T23:36:17.355"/>
+  </p1510:revLst>
+</p1510:revInfo>
+</file>
+
+<file path=ppt/changesInfos/changesInfo1.xml><?xml version="1.0" encoding="utf-8"?>
+<pc:chgInfo xmlns:a="http://schemas.openxmlformats.org/drawingml/2006/main" xmlns:r="http://schemas.openxmlformats.org/officeDocument/2006/relationships" xmlns:ac="http://schemas.microsoft.com/office/drawing/2013/main/command" xmlns:pc="http://schemas.microsoft.com/office/powerpoint/2013/main/command">
+  <pc:docChgLst>
+    <pc:chgData name="Martin Alvarez" userId="10705b4323551338" providerId="LiveId" clId="{9DFD7805-24BF-4A68-BB66-FC44D414A98A}"/>
+    <pc:docChg chg="undo custSel modSld">
+      <pc:chgData name="Martin Alvarez" userId="10705b4323551338" providerId="LiveId" clId="{9DFD7805-24BF-4A68-BB66-FC44D414A98A}" dt="2025-11-02T23:38:22.259" v="346" actId="123"/>
+      <pc:docMkLst>
+        <pc:docMk/>
+      </pc:docMkLst>
+      <pc:sldChg chg="modSp mod">
+        <pc:chgData name="Martin Alvarez" userId="10705b4323551338" providerId="LiveId" clId="{9DFD7805-24BF-4A68-BB66-FC44D414A98A}" dt="2025-11-02T23:35:54.189" v="330" actId="14100"/>
+        <pc:sldMkLst>
+          <pc:docMk/>
+          <pc:sldMk cId="2257239353" sldId="430"/>
+        </pc:sldMkLst>
+        <pc:spChg chg="mod">
+          <ac:chgData name="Martin Alvarez" userId="10705b4323551338" providerId="LiveId" clId="{9DFD7805-24BF-4A68-BB66-FC44D414A98A}" dt="2025-11-02T23:35:54.189" v="330" actId="14100"/>
+          <ac:spMkLst>
+            <pc:docMk/>
+            <pc:sldMk cId="2257239353" sldId="430"/>
+            <ac:spMk id="4" creationId="{3A98B716-D772-C5D0-8F2B-0FC170A121B3}"/>
+          </ac:spMkLst>
+        </pc:spChg>
+        <pc:spChg chg="mod">
+          <ac:chgData name="Martin Alvarez" userId="10705b4323551338" providerId="LiveId" clId="{9DFD7805-24BF-4A68-BB66-FC44D414A98A}" dt="2025-11-02T23:18:00.285" v="197" actId="20577"/>
+          <ac:spMkLst>
+            <pc:docMk/>
+            <pc:sldMk cId="2257239353" sldId="430"/>
+            <ac:spMk id="7" creationId="{51866271-BB68-1526-2CE7-3384380E94B7}"/>
+          </ac:spMkLst>
+        </pc:spChg>
+      </pc:sldChg>
+      <pc:sldChg chg="addSp modSp mod">
+        <pc:chgData name="Martin Alvarez" userId="10705b4323551338" providerId="LiveId" clId="{9DFD7805-24BF-4A68-BB66-FC44D414A98A}" dt="2025-11-02T23:36:57.237" v="344" actId="20577"/>
+        <pc:sldMkLst>
+          <pc:docMk/>
+          <pc:sldMk cId="291770541" sldId="509"/>
+        </pc:sldMkLst>
+        <pc:spChg chg="mod">
+          <ac:chgData name="Martin Alvarez" userId="10705b4323551338" providerId="LiveId" clId="{9DFD7805-24BF-4A68-BB66-FC44D414A98A}" dt="2025-11-02T23:36:57.237" v="344" actId="20577"/>
+          <ac:spMkLst>
+            <pc:docMk/>
+            <pc:sldMk cId="291770541" sldId="509"/>
+            <ac:spMk id="3" creationId="{5EFBAC98-1603-F9AA-6641-050699825C75}"/>
+          </ac:spMkLst>
+        </pc:spChg>
+        <pc:spChg chg="add mod">
+          <ac:chgData name="Martin Alvarez" userId="10705b4323551338" providerId="LiveId" clId="{9DFD7805-24BF-4A68-BB66-FC44D414A98A}" dt="2025-11-02T23:32:09.318" v="327" actId="255"/>
+          <ac:spMkLst>
+            <pc:docMk/>
+            <pc:sldMk cId="291770541" sldId="509"/>
+            <ac:spMk id="5" creationId="{87996BE8-25B4-523F-AA02-BF8D463CBC00}"/>
+          </ac:spMkLst>
+        </pc:spChg>
+      </pc:sldChg>
+      <pc:sldChg chg="modSp mod">
+        <pc:chgData name="Martin Alvarez" userId="10705b4323551338" providerId="LiveId" clId="{9DFD7805-24BF-4A68-BB66-FC44D414A98A}" dt="2025-11-02T23:38:22.259" v="346" actId="123"/>
+        <pc:sldMkLst>
+          <pc:docMk/>
+          <pc:sldMk cId="2359871389" sldId="510"/>
+        </pc:sldMkLst>
+        <pc:spChg chg="mod">
+          <ac:chgData name="Martin Alvarez" userId="10705b4323551338" providerId="LiveId" clId="{9DFD7805-24BF-4A68-BB66-FC44D414A98A}" dt="2025-11-02T23:38:22.259" v="346" actId="123"/>
+          <ac:spMkLst>
+            <pc:docMk/>
+            <pc:sldMk cId="2359871389" sldId="510"/>
+            <ac:spMk id="3" creationId="{18B5CB80-2569-DB6C-6C50-FF38A2007868}"/>
+          </ac:spMkLst>
+        </pc:spChg>
+      </pc:sldChg>
+      <pc:sldChg chg="modSp mod">
+        <pc:chgData name="Martin Alvarez" userId="10705b4323551338" providerId="LiveId" clId="{9DFD7805-24BF-4A68-BB66-FC44D414A98A}" dt="2025-11-02T23:38:03.757" v="345" actId="123"/>
+        <pc:sldMkLst>
+          <pc:docMk/>
+          <pc:sldMk cId="3894861376" sldId="511"/>
+        </pc:sldMkLst>
+        <pc:spChg chg="mod">
+          <ac:chgData name="Martin Alvarez" userId="10705b4323551338" providerId="LiveId" clId="{9DFD7805-24BF-4A68-BB66-FC44D414A98A}" dt="2025-11-02T23:38:03.757" v="345" actId="123"/>
+          <ac:spMkLst>
+            <pc:docMk/>
+            <pc:sldMk cId="3894861376" sldId="511"/>
+            <ac:spMk id="3" creationId="{059534CE-444D-81AC-A5D2-6055B5D2DD8C}"/>
+          </ac:spMkLst>
+        </pc:spChg>
+      </pc:sldChg>
+    </pc:docChg>
+  </pc:docChgLst>
+</pc:chgInfo>
+</file>
+
 <file path=ppt/notesMasters/notesMaster1.xml><?xml version="1.0" encoding="utf-8"?>
 <p:notesMaster xmlns:a="http://schemas.openxmlformats.org/drawingml/2006/main" xmlns:r="http://schemas.openxmlformats.org/officeDocument/2006/relationships" xmlns:p="http://schemas.openxmlformats.org/presentationml/2006/main">
   <p:cSld>
@@ -201,7 +299,7 @@
           <a:p>
             <a:fld id="{18C64025-9F1C-B54C-874D-6AE83D7874AF}" type="datetimeFigureOut">
               <a:rPr lang="en-US" smtClean="0"/>
-              <a:t>10/28/2025</a:t>
+              <a:t>11/2/2025</a:t>
             </a:fld>
             <a:endParaRPr lang="en-US"/>
           </a:p>
@@ -697,9 +795,9 @@
           <a:bodyPr/>
           <a:lstStyle/>
           <a:p>
-            <a:fld id="{5569E8CE-0F35-F541-BCBD-B6195E92A87C}" type="datetime1">
+            <a:fld id="{5553EB80-F412-4264-877A-F519E86134B6}" type="datetime1">
               <a:rPr lang="en-US" smtClean="0"/>
-              <a:t>10/28/2025</a:t>
+              <a:t>11/2/2025</a:t>
             </a:fld>
             <a:endParaRPr lang="en-US"/>
           </a:p>
@@ -895,9 +993,9 @@
           <a:bodyPr/>
           <a:lstStyle/>
           <a:p>
-            <a:fld id="{AE79076C-0815-964C-A5EB-391D5811865D}" type="datetime1">
+            <a:fld id="{862EE02B-0F43-4052-B629-74101F7A2B1E}" type="datetime1">
               <a:rPr lang="en-US" smtClean="0"/>
-              <a:t>10/28/2025</a:t>
+              <a:t>11/2/2025</a:t>
             </a:fld>
             <a:endParaRPr lang="en-US"/>
           </a:p>
@@ -1103,9 +1201,9 @@
           <a:bodyPr/>
           <a:lstStyle/>
           <a:p>
-            <a:fld id="{2CB252A1-199D-114C-9638-8F4E0A0E3B4E}" type="datetime1">
+            <a:fld id="{BA91AF33-61B0-4EF0-A0BC-F5D1F49ED75E}" type="datetime1">
               <a:rPr lang="en-US" smtClean="0"/>
-              <a:t>10/28/2025</a:t>
+              <a:t>11/2/2025</a:t>
             </a:fld>
             <a:endParaRPr lang="en-US"/>
           </a:p>
@@ -1301,9 +1399,9 @@
           <a:bodyPr/>
           <a:lstStyle/>
           <a:p>
-            <a:fld id="{D608A790-CB55-8445-A175-4B755B616B28}" type="datetime1">
+            <a:fld id="{DAED59A3-20FD-4F57-BF6F-3BA27807FCD6}" type="datetime1">
               <a:rPr lang="en-US" smtClean="0"/>
-              <a:t>10/28/2025</a:t>
+              <a:t>11/2/2025</a:t>
             </a:fld>
             <a:endParaRPr lang="en-US"/>
           </a:p>
@@ -1576,9 +1674,9 @@
           <a:bodyPr/>
           <a:lstStyle/>
           <a:p>
-            <a:fld id="{E8F90DB7-12FD-E040-A571-9A2A9953F039}" type="datetime1">
+            <a:fld id="{537898AC-FD9A-4750-9FD7-40423F078F72}" type="datetime1">
               <a:rPr lang="en-US" smtClean="0"/>
-              <a:t>10/28/2025</a:t>
+              <a:t>11/2/2025</a:t>
             </a:fld>
             <a:endParaRPr lang="en-US"/>
           </a:p>
@@ -1841,9 +1939,9 @@
           <a:bodyPr/>
           <a:lstStyle/>
           <a:p>
-            <a:fld id="{56D09A57-CF75-A84D-B555-C90632D140A8}" type="datetime1">
+            <a:fld id="{BFCD715A-4944-4C29-B77B-A34E4EBD5D1C}" type="datetime1">
               <a:rPr lang="en-US" smtClean="0"/>
-              <a:t>10/28/2025</a:t>
+              <a:t>11/2/2025</a:t>
             </a:fld>
             <a:endParaRPr lang="en-US"/>
           </a:p>
@@ -2253,9 +2351,9 @@
           <a:bodyPr/>
           <a:lstStyle/>
           <a:p>
-            <a:fld id="{87132B89-5B15-7440-93D9-E782F3BE191D}" type="datetime1">
+            <a:fld id="{2CACFED3-771D-4033-9854-1BCE9F349520}" type="datetime1">
               <a:rPr lang="en-US" smtClean="0"/>
-              <a:t>10/28/2025</a:t>
+              <a:t>11/2/2025</a:t>
             </a:fld>
             <a:endParaRPr lang="en-US"/>
           </a:p>
@@ -2394,9 +2492,9 @@
           <a:bodyPr/>
           <a:lstStyle/>
           <a:p>
-            <a:fld id="{52F6A7CC-2D97-2345-8DAD-4A37DF7413EF}" type="datetime1">
+            <a:fld id="{3BFA0130-DE1D-4A6F-857A-8C219800B683}" type="datetime1">
               <a:rPr lang="en-US" smtClean="0"/>
-              <a:t>10/28/2025</a:t>
+              <a:t>11/2/2025</a:t>
             </a:fld>
             <a:endParaRPr lang="en-US"/>
           </a:p>
@@ -2507,9 +2605,9 @@
           <a:bodyPr/>
           <a:lstStyle/>
           <a:p>
-            <a:fld id="{FC740053-99FC-2C4C-AE81-1DDDD66DA84F}" type="datetime1">
+            <a:fld id="{3F288EC0-6D5A-4D19-A435-0941F570E284}" type="datetime1">
               <a:rPr lang="en-US" smtClean="0"/>
-              <a:t>10/28/2025</a:t>
+              <a:t>11/2/2025</a:t>
             </a:fld>
             <a:endParaRPr lang="en-US"/>
           </a:p>
@@ -2818,9 +2916,9 @@
           <a:bodyPr/>
           <a:lstStyle/>
           <a:p>
-            <a:fld id="{976F9FEC-A4E3-6F42-99D7-60930184D62D}" type="datetime1">
+            <a:fld id="{D3202220-7A39-491A-AB5F-1E807CD87A70}" type="datetime1">
               <a:rPr lang="en-US" smtClean="0"/>
-              <a:t>10/28/2025</a:t>
+              <a:t>11/2/2025</a:t>
             </a:fld>
             <a:endParaRPr lang="en-US"/>
           </a:p>
@@ -3106,9 +3204,9 @@
           <a:bodyPr/>
           <a:lstStyle/>
           <a:p>
-            <a:fld id="{F7B0929B-4D46-C442-8791-A547B3D6087C}" type="datetime1">
+            <a:fld id="{ED06D8C2-DA25-477C-9AE3-885A59B8917A}" type="datetime1">
               <a:rPr lang="en-US" smtClean="0"/>
-              <a:t>10/28/2025</a:t>
+              <a:t>11/2/2025</a:t>
             </a:fld>
             <a:endParaRPr lang="en-US"/>
           </a:p>
@@ -3349,9 +3447,9 @@
             </a:lvl1pPr>
           </a:lstStyle>
           <a:p>
-            <a:fld id="{4E078F21-4140-5E40-B327-1420A46649A6}" type="datetime1">
+            <a:fld id="{67D64D48-C016-4A3B-B5A2-1F0B064B80AA}" type="datetime1">
               <a:rPr lang="en-US" noProof="0" smtClean="0"/>
-              <a:t>10/28/2025</a:t>
+              <a:t>11/2/2025</a:t>
             </a:fld>
             <a:endParaRPr lang="es-ES_tradnl" noProof="0"/>
           </a:p>
@@ -4073,7 +4171,7 @@
               <a:rPr lang="en-US" smtClean="0"/>
               <a:t>2</a:t>
             </a:fld>
-            <a:endParaRPr lang="en-US"/>
+            <a:endParaRPr lang="en-US" dirty="0"/>
           </a:p>
         </p:txBody>
       </p:sp>
@@ -4105,7 +4203,7 @@
           </a:bodyPr>
           <a:lstStyle/>
           <a:p>
-            <a:pPr marL="0" indent="0">
+            <a:pPr marL="0" indent="0" algn="just">
               <a:lnSpc>
                 <a:spcPct val="120000"/>
               </a:lnSpc>
@@ -4115,23 +4213,11 @@
               <a:rPr lang="es-ES_tradnl" sz="2400" dirty="0">
                 <a:latin typeface="Gill Sans Nova Light" panose="020B0302020104020203" pitchFamily="34" charset="0"/>
               </a:rPr>
-              <a:t>Base de datos: oferta inmuebles en distintos países de </a:t>
-            </a:r>
-            <a:r>
-              <a:rPr lang="es-ES_tradnl" sz="2400" dirty="0" err="1">
-                <a:latin typeface="Gill Sans Nova Light" panose="020B0302020104020203" pitchFamily="34" charset="0"/>
-              </a:rPr>
-              <a:t>America</a:t>
-            </a:r>
-            <a:r>
-              <a:rPr lang="es-ES_tradnl" sz="2400" dirty="0">
-                <a:latin typeface="Gill Sans Nova Light" panose="020B0302020104020203" pitchFamily="34" charset="0"/>
-              </a:rPr>
-              <a:t> Latina y el mundo.</a:t>
-            </a:r>
-          </a:p>
-          <a:p>
-            <a:pPr marL="0" indent="0">
+              <a:t>Base de datos: oferta de inmuebles en distintos países de América Latina y el mundo.</a:t>
+            </a:r>
+          </a:p>
+          <a:p>
+            <a:pPr marL="0" indent="0" algn="just">
               <a:lnSpc>
                 <a:spcPct val="120000"/>
               </a:lnSpc>
@@ -4159,14 +4245,14 @@
               <a:rPr lang="es-AR" sz="2400" dirty="0">
                 <a:latin typeface="Gill Sans Nova Light" panose="020B0302020104020203" pitchFamily="34" charset="0"/>
               </a:rPr>
-              <a:t>portal inmobiliario líder en Argentina que se especializa en la publicación y búsqueda de propiedades para la venta y alquiler.</a:t>
+              <a:t>portal inmobiliario líder en Argentina que se especializa en la publicación y búsqueda de propiedades para venta y alquiler.</a:t>
             </a:r>
             <a:endParaRPr lang="es-ES_tradnl" sz="2400" dirty="0">
               <a:latin typeface="Gill Sans Nova Light" panose="020B0302020104020203" pitchFamily="34" charset="0"/>
             </a:endParaRPr>
           </a:p>
           <a:p>
-            <a:pPr marL="0" indent="0">
+            <a:pPr marL="0" indent="0" algn="just">
               <a:lnSpc>
                 <a:spcPct val="120000"/>
               </a:lnSpc>
@@ -4180,7 +4266,7 @@
             </a:r>
           </a:p>
           <a:p>
-            <a:pPr marL="0" indent="0">
+            <a:pPr marL="0" indent="0" algn="just">
               <a:lnSpc>
                 <a:spcPct val="120000"/>
               </a:lnSpc>
@@ -4190,11 +4276,11 @@
               <a:rPr lang="es-ES_tradnl" sz="2400" dirty="0">
                 <a:latin typeface="Gill Sans Nova Light" panose="020B0302020104020203" pitchFamily="34" charset="0"/>
               </a:rPr>
-              <a:t>Periodicidad: Mensual. Cabe destacar que mes a mes se hacen actualiza la oferta y se detalla la fecha de publicación de cada inmueble.</a:t>
-            </a:r>
-          </a:p>
-          <a:p>
-            <a:pPr marL="0" indent="0">
+              <a:t>Periodicidad: mensual. Se actualiza el stock de oferta y se detalla la fecha de publicación de cada inmueble. Es decir, la base de septiembre puede tener observaciones con fecha de publicación en meses o años anteriores que no se concretaron y siguen disponibles.</a:t>
+            </a:r>
+          </a:p>
+          <a:p>
+            <a:pPr marL="0" indent="0" algn="just">
               <a:lnSpc>
                 <a:spcPct val="120000"/>
               </a:lnSpc>
@@ -4325,64 +4411,255 @@
         </p:nvSpPr>
         <p:spPr>
           <a:xfrm>
-            <a:off x="838200" y="1690688"/>
-            <a:ext cx="10515600" cy="4351338"/>
+            <a:off x="838200" y="2484120"/>
+            <a:ext cx="10515600" cy="3557906"/>
           </a:xfrm>
         </p:spPr>
         <p:txBody>
-          <a:bodyPr>
-            <a:normAutofit/>
+          <a:bodyPr numCol="2">
+            <a:noAutofit/>
           </a:bodyPr>
           <a:lstStyle/>
           <a:p>
-            <a:pPr marL="0" indent="0">
+            <a:pPr algn="just">
               <a:lnSpc>
                 <a:spcPct val="120000"/>
               </a:lnSpc>
-              <a:buNone/>
             </a:pPr>
             <a:r>
               <a:rPr lang="es-ES_tradnl" sz="2400" dirty="0">
                 <a:latin typeface="Gill Sans Nova Light" panose="020B0302020104020203" pitchFamily="34" charset="0"/>
               </a:rPr>
-              <a:t>Total de variables: 26</a:t>
-            </a:r>
-          </a:p>
-          <a:p>
-            <a:pPr marL="0" indent="0">
+              <a:t>país </a:t>
+            </a:r>
+          </a:p>
+          <a:p>
+            <a:pPr algn="just">
               <a:lnSpc>
                 <a:spcPct val="120000"/>
               </a:lnSpc>
-              <a:buNone/>
             </a:pPr>
             <a:r>
               <a:rPr lang="es-ES_tradnl" sz="2400" dirty="0">
                 <a:latin typeface="Gill Sans Nova Light" panose="020B0302020104020203" pitchFamily="34" charset="0"/>
               </a:rPr>
-              <a:t>Entre las variables más importantes, destacan: país, provincia, localidad, barrio, tipo de propiedad, tipo de operación, latitud, longitud, nombre (moneda de operación), superficie total, cantidad de ambientes y antigüedad.</a:t>
-            </a:r>
-          </a:p>
-          <a:p>
-            <a:pPr marL="0" indent="0">
+              <a:t>provincia </a:t>
+            </a:r>
+          </a:p>
+          <a:p>
+            <a:pPr algn="just">
               <a:lnSpc>
                 <a:spcPct val="120000"/>
               </a:lnSpc>
-              <a:buNone/>
+            </a:pPr>
+            <a:r>
+              <a:rPr lang="es-ES_tradnl" sz="2400" dirty="0">
+                <a:latin typeface="Gill Sans Nova Light" panose="020B0302020104020203" pitchFamily="34" charset="0"/>
+              </a:rPr>
+              <a:t>localidad </a:t>
+            </a:r>
+          </a:p>
+          <a:p>
+            <a:pPr algn="just">
+              <a:lnSpc>
+                <a:spcPct val="120000"/>
+              </a:lnSpc>
+            </a:pPr>
+            <a:r>
+              <a:rPr lang="es-ES_tradnl" sz="2400" dirty="0">
+                <a:latin typeface="Gill Sans Nova Light" panose="020B0302020104020203" pitchFamily="34" charset="0"/>
+              </a:rPr>
+              <a:t>barrio</a:t>
+            </a:r>
+          </a:p>
+          <a:p>
+            <a:pPr algn="just">
+              <a:lnSpc>
+                <a:spcPct val="120000"/>
+              </a:lnSpc>
+            </a:pPr>
+            <a:r>
+              <a:rPr lang="es-ES_tradnl" sz="2400" dirty="0">
+                <a:latin typeface="Gill Sans Nova Light" panose="020B0302020104020203" pitchFamily="34" charset="0"/>
+              </a:rPr>
+              <a:t>tipo de propiedad</a:t>
+            </a:r>
+          </a:p>
+          <a:p>
+            <a:pPr algn="just">
+              <a:lnSpc>
+                <a:spcPct val="120000"/>
+              </a:lnSpc>
+            </a:pPr>
+            <a:r>
+              <a:rPr lang="es-ES_tradnl" sz="2400" dirty="0">
+                <a:latin typeface="Gill Sans Nova Light" panose="020B0302020104020203" pitchFamily="34" charset="0"/>
+              </a:rPr>
+              <a:t>tipo de operación </a:t>
+            </a:r>
+          </a:p>
+          <a:p>
+            <a:pPr algn="just">
+              <a:lnSpc>
+                <a:spcPct val="120000"/>
+              </a:lnSpc>
             </a:pPr>
             <a:endParaRPr lang="es-ES_tradnl" sz="2400" dirty="0">
               <a:latin typeface="Gill Sans Nova Light" panose="020B0302020104020203" pitchFamily="34" charset="0"/>
             </a:endParaRPr>
           </a:p>
           <a:p>
-            <a:pPr marL="0" indent="0">
+            <a:pPr algn="just">
               <a:lnSpc>
                 <a:spcPct val="120000"/>
               </a:lnSpc>
-              <a:buNone/>
             </a:pPr>
             <a:endParaRPr lang="es-ES_tradnl" sz="2400" dirty="0">
               <a:latin typeface="Gill Sans Nova Light" panose="020B0302020104020203" pitchFamily="34" charset="0"/>
             </a:endParaRPr>
+          </a:p>
+          <a:p>
+            <a:pPr algn="just">
+              <a:lnSpc>
+                <a:spcPct val="120000"/>
+              </a:lnSpc>
+            </a:pPr>
+            <a:r>
+              <a:rPr lang="es-ES_tradnl" sz="2400" dirty="0">
+                <a:latin typeface="Gill Sans Nova Light" panose="020B0302020104020203" pitchFamily="34" charset="0"/>
+              </a:rPr>
+              <a:t>latitud</a:t>
+            </a:r>
+          </a:p>
+          <a:p>
+            <a:pPr algn="just">
+              <a:lnSpc>
+                <a:spcPct val="120000"/>
+              </a:lnSpc>
+            </a:pPr>
+            <a:r>
+              <a:rPr lang="es-ES_tradnl" sz="2400" dirty="0">
+                <a:latin typeface="Gill Sans Nova Light" panose="020B0302020104020203" pitchFamily="34" charset="0"/>
+              </a:rPr>
+              <a:t>longitud</a:t>
+            </a:r>
+          </a:p>
+          <a:p>
+            <a:pPr algn="just">
+              <a:lnSpc>
+                <a:spcPct val="120000"/>
+              </a:lnSpc>
+            </a:pPr>
+            <a:r>
+              <a:rPr lang="es-ES_tradnl" sz="2400" dirty="0">
+                <a:latin typeface="Gill Sans Nova Light" panose="020B0302020104020203" pitchFamily="34" charset="0"/>
+              </a:rPr>
+              <a:t>nombre (moneda de operación) </a:t>
+            </a:r>
+          </a:p>
+          <a:p>
+            <a:pPr algn="just">
+              <a:lnSpc>
+                <a:spcPct val="120000"/>
+              </a:lnSpc>
+            </a:pPr>
+            <a:r>
+              <a:rPr lang="es-ES_tradnl" sz="2400" dirty="0">
+                <a:latin typeface="Gill Sans Nova Light" panose="020B0302020104020203" pitchFamily="34" charset="0"/>
+              </a:rPr>
+              <a:t>superficie total (cubierta y descubierta)</a:t>
+            </a:r>
+          </a:p>
+          <a:p>
+            <a:pPr algn="just">
+              <a:lnSpc>
+                <a:spcPct val="120000"/>
+              </a:lnSpc>
+            </a:pPr>
+            <a:r>
+              <a:rPr lang="es-ES_tradnl" sz="2400" dirty="0">
+                <a:latin typeface="Gill Sans Nova Light" panose="020B0302020104020203" pitchFamily="34" charset="0"/>
+              </a:rPr>
+              <a:t>cantidad de ambientes </a:t>
+            </a:r>
+          </a:p>
+          <a:p>
+            <a:pPr algn="just">
+              <a:lnSpc>
+                <a:spcPct val="120000"/>
+              </a:lnSpc>
+            </a:pPr>
+            <a:r>
+              <a:rPr lang="es-ES_tradnl" sz="2400" dirty="0">
+                <a:latin typeface="Gill Sans Nova Light" panose="020B0302020104020203" pitchFamily="34" charset="0"/>
+              </a:rPr>
+              <a:t>antigüedad</a:t>
+            </a:r>
+          </a:p>
+          <a:p>
+            <a:pPr marL="0" indent="0" algn="just">
+              <a:lnSpc>
+                <a:spcPct val="120000"/>
+              </a:lnSpc>
+              <a:buNone/>
+            </a:pPr>
+            <a:endParaRPr lang="es-ES_tradnl" sz="2400" dirty="0">
+              <a:latin typeface="Gill Sans Nova Light" panose="020B0302020104020203" pitchFamily="34" charset="0"/>
+            </a:endParaRPr>
+          </a:p>
+          <a:p>
+            <a:pPr marL="0" indent="0" algn="just">
+              <a:lnSpc>
+                <a:spcPct val="120000"/>
+              </a:lnSpc>
+              <a:buNone/>
+            </a:pPr>
+            <a:endParaRPr lang="es-ES_tradnl" sz="2400" dirty="0">
+              <a:latin typeface="Gill Sans Nova Light" panose="020B0302020104020203" pitchFamily="34" charset="0"/>
+            </a:endParaRPr>
+          </a:p>
+        </p:txBody>
+      </p:sp>
+      <p:sp>
+        <p:nvSpPr>
+          <p:cNvPr id="5" name="CuadroTexto 4">
+            <a:extLst>
+              <a:ext uri="{FF2B5EF4-FFF2-40B4-BE49-F238E27FC236}">
+                <a16:creationId xmlns:a16="http://schemas.microsoft.com/office/drawing/2014/main" id="{87996BE8-25B4-523F-AA02-BF8D463CBC00}"/>
+              </a:ext>
+            </a:extLst>
+          </p:cNvPr>
+          <p:cNvSpPr txBox="1"/>
+          <p:nvPr/>
+        </p:nvSpPr>
+        <p:spPr>
+          <a:xfrm>
+            <a:off x="838200" y="1432560"/>
+            <a:ext cx="10515600" cy="951864"/>
+          </a:xfrm>
+          <a:prstGeom prst="rect">
+            <a:avLst/>
+          </a:prstGeom>
+          <a:noFill/>
+        </p:spPr>
+        <p:txBody>
+          <a:bodyPr wrap="square" rtlCol="0">
+            <a:spAutoFit/>
+          </a:bodyPr>
+          <a:lstStyle/>
+          <a:p>
+            <a:pPr algn="just">
+              <a:lnSpc>
+                <a:spcPct val="120000"/>
+              </a:lnSpc>
+            </a:pPr>
+            <a:r>
+              <a:rPr lang="es-ES_tradnl" sz="2400" dirty="0">
+                <a:latin typeface="Gill Sans Nova Light" panose="020B0302020104020203" pitchFamily="34" charset="0"/>
+              </a:rPr>
+              <a:t>La base de datos cuenta con 26 variables. Entre las variables más importantes, destacan:</a:t>
+            </a:r>
+            <a:endParaRPr lang="es-AR" sz="2400" dirty="0"/>
           </a:p>
         </p:txBody>
       </p:sp>
@@ -4515,7 +4792,7 @@
           </a:bodyPr>
           <a:lstStyle/>
           <a:p>
-            <a:pPr marL="0" indent="0">
+            <a:pPr marL="0" indent="0" algn="just">
               <a:lnSpc>
                 <a:spcPct val="120000"/>
               </a:lnSpc>
@@ -4547,7 +4824,7 @@
             </a:r>
           </a:p>
           <a:p>
-            <a:pPr marL="0" indent="0">
+            <a:pPr marL="0" indent="0" algn="just">
               <a:lnSpc>
                 <a:spcPct val="120000"/>
               </a:lnSpc>
@@ -4693,7 +4970,7 @@
           </a:bodyPr>
           <a:lstStyle/>
           <a:p>
-            <a:pPr marL="0" indent="0">
+            <a:pPr marL="0" indent="0" algn="just">
               <a:lnSpc>
                 <a:spcPct val="120000"/>
               </a:lnSpc>
@@ -4741,7 +5018,7 @@
             </a:r>
           </a:p>
           <a:p>
-            <a:pPr marL="0" indent="0">
+            <a:pPr marL="0" indent="0" algn="just">
               <a:lnSpc>
                 <a:spcPct val="120000"/>
               </a:lnSpc>
@@ -4773,7 +5050,7 @@
             </a:r>
           </a:p>
           <a:p>
-            <a:pPr marL="0" indent="0">
+            <a:pPr marL="0" indent="0" algn="just">
               <a:lnSpc>
                 <a:spcPct val="120000"/>
               </a:lnSpc>

</xml_diff>